<commit_message>
Refactor models.json to reorganize ksul-gpt provider configuration
</commit_message>
<xml_diff>
--- a/LLMs-101-v2.pptx
+++ b/LLMs-101-v2.pptx
@@ -3029,7 +3029,7 @@
                 <a:ea typeface="Calibri" pitchFamily="34" charset="-122"/>
                 <a:cs typeface="Calibri" pitchFamily="34" charset="-120"/>
               </a:rPr>
-              <a:t>How these things actually work, what they cost to run, and how to use them without getting burned.</a:t>
+              <a:t>Chatting to Agents and the Engine Under the Hood</a:t>
             </a:r>
             <a:endParaRPr lang="en-US" sz="2100" dirty="0"/>
           </a:p>
@@ -3134,7 +3134,7 @@
                 <a:ea typeface="Calibri" pitchFamily="34" charset="-122"/>
                 <a:cs typeface="Calibri" pitchFamily="34" charset="-120"/>
               </a:rPr>
-              <a:t>Sawyer Borror  ·  Library IT  ·  Hale Library, AI Studio</a:t>
+              <a:t>Sawyer Borror|sawyerb@ksu.edu  ·  Library IT  ·  Hale Library, Sunderland AI Studio</a:t>
             </a:r>
             <a:endParaRPr lang="en-US" sz="1400" dirty="0"/>
           </a:p>
@@ -5976,7 +5976,7 @@
                 <a:ea typeface="Calibri" pitchFamily="34" charset="-122"/>
                 <a:cs typeface="Calibri" pitchFamily="34" charset="-120"/>
               </a:rPr>
-              <a:t>Approved for sensitive data</a:t>
+              <a:t>Safe for sensitive data</a:t>
             </a:r>
             <a:endParaRPr lang="en-US" sz="1300" dirty="0"/>
           </a:p>
@@ -5997,7 +5997,7 @@
                 <a:ea typeface="Calibri" pitchFamily="34" charset="-122"/>
                 <a:cs typeface="Calibri" pitchFamily="34" charset="-120"/>
               </a:rPr>
-              <a:t>Patron and reference data</a:t>
+              <a:t>More complex or demanding tasks</a:t>
             </a:r>
             <a:endParaRPr lang="en-US" sz="1300" dirty="0"/>
           </a:p>
@@ -6018,7 +6018,7 @@
                 <a:ea typeface="Calibri" pitchFamily="34" charset="-122"/>
                 <a:cs typeface="Calibri" pitchFamily="34" charset="-120"/>
               </a:rPr>
-              <a:t>ILL notes, student work</a:t>
+              <a:t>Exploring new models safely</a:t>
             </a:r>
             <a:endParaRPr lang="en-US" sz="1300" dirty="0"/>
           </a:p>
@@ -10576,7 +10576,7 @@
                 <a:ea typeface="Calibri" pitchFamily="34" charset="-122"/>
                 <a:cs typeface="Calibri" pitchFamily="34" charset="-120"/>
               </a:rPr>
-              <a:t>Hold that thought — it's the first case study in section 4. (This one was cleared with campus IT.)</a:t>
+              <a:t>Hold that thought — it's the first case study in section 4.</a:t>
             </a:r>
             <a:endParaRPr lang="en-US" sz="1400" dirty="0"/>
           </a:p>
@@ -10711,7 +10711,7 @@
                 <a:ea typeface="Cambria" pitchFamily="34" charset="-122"/>
                 <a:cs typeface="Cambria" pitchFamily="34" charset="-120"/>
               </a:rPr>
-              <a:t>What a harness is actually good for in a library</a:t>
+              <a:t>What a harness is actually good for</a:t>
             </a:r>
             <a:endParaRPr lang="en-US" sz="3000" dirty="0"/>
           </a:p>
@@ -18934,7 +18934,7 @@
                 <a:ea typeface="Calibri" pitchFamily="34" charset="-122"/>
                 <a:cs typeface="Calibri" pitchFamily="34" charset="-120"/>
               </a:rPr>
-              <a:t>github.com/sawyerb-ksu/llms-101  ·  pi.dev/docs  ·  ollama.com  ·  and me — bring your repetitive task.</a:t>
+              <a:t>github.com/sawyerb-ksu/llms-101  ·  pi.dev/docs  ·  ollama.com  ·  and me — lets create solutions!</a:t>
             </a:r>
             <a:endParaRPr lang="en-US" sz="1600" dirty="0"/>
           </a:p>

</xml_diff>